<commit_message>
Cập nhật slide và tài liệu Use Case cho khớp với app: Kotlin/Compose/SQLite, Use Case mới, đặc tả đúng luồng, sửa thông tin khảo sát
</commit_message>
<xml_diff>
--- a/docs/SubTrack_GioiThieuDeTai.pptx
+++ b/docs/SubTrack_GioiThieuDeTai.pptx
@@ -118,7 +118,7 @@
   <p:extLst>
     <p:ext uri="{521415D9-36F7-43E2-AB2F-B90AF26B5E84}">
       <p14:sectionLst xmlns:p14="http://schemas.microsoft.com/office/powerpoint/2010/main">
-        <p14:section name="Giới thiệu" id="{c1a69626-42a8-3f9d-f1a4-0e0690685eb4}">
+        <p14:section name="Giới thiệu" id="{2f4c87c8-1067-23da-57b1-4d7103a885b8}">
           <p14:sldIdLst>
             <p14:sldId id="256"/>
             <p14:sldId id="257"/>
@@ -126,19 +126,19 @@
             <p14:sldId id="259"/>
           </p14:sldIdLst>
         </p14:section>
-        <p14:section name="Khảo sát" id="{8f74127b-796d-e174-2ec2-2dd5dbf66d5e}">
+        <p14:section name="Khảo sát" id="{8174516b-7483-99aa-0d8e-374c601d8942}">
           <p14:sldIdLst>
             <p14:sldId id="260"/>
           </p14:sldIdLst>
         </p14:section>
-        <p14:section name="Chức năng" id="{08dd189e-6156-4791-3a5a-fd110981c561}">
+        <p14:section name="Chức năng" id="{1a296dec-8bf7-2d14-c63a-3c113c0e46f5}">
           <p14:sldIdLst>
             <p14:sldId id="261"/>
             <p14:sldId id="262"/>
             <p14:sldId id="263"/>
           </p14:sldIdLst>
         </p14:section>
-        <p14:section name="Triển khai" id="{47a44a73-6862-cb9c-b19a-ed13f86cae0d}">
+        <p14:section name="Triển khai" id="{ffd2f57a-9816-f4fa-ecd0-453bcbbd7555}">
           <p14:sldIdLst>
             <p14:sldId id="264"/>
             <p14:sldId id="265"/>
@@ -2966,7 +2966,7 @@
                   <a:srgbClr val="4A4560"/>
                 </a:solidFill>
               </a:rPr>
-              <a:t>Form thêm/sửa, màn hình chi tiết</a:t>
+              <a:t>Form thêm/sửa gói, xác nhận xóa</a:t>
             </a:r>
             <a:endParaRPr lang="en-US" sz="1400" dirty="0"/>
           </a:p>
@@ -3183,7 +3183,7 @@
                   <a:schemeClr val="tx2"/>
                 </a:solidFill>
               </a:rPr>
-              <a:t>Database &amp; bảo mật</a:t>
+              <a:t>Database &amp; dữ liệu</a:t>
             </a:r>
             <a:endParaRPr lang="en-US" sz="1900" dirty="0"/>
           </a:p>
@@ -3223,7 +3223,7 @@
                   <a:srgbClr val="4A4560"/>
                 </a:solidFill>
               </a:rPr>
-              <a:t>Schema, cấu hình Firebase</a:t>
+              <a:t>Schema SQLite, ERD</a:t>
             </a:r>
             <a:endParaRPr lang="en-US" sz="1400" dirty="0"/>
           </a:p>
@@ -3259,7 +3259,7 @@
                   <a:srgbClr val="4A4560"/>
                 </a:solidFill>
               </a:rPr>
-              <a:t>Xác thực, quy tắc truy cập, ERD</a:t>
+              <a:t>Cài đặt, xuất CSV, dữ liệu mẫu</a:t>
             </a:r>
             <a:endParaRPr lang="en-US" sz="1400" dirty="0"/>
           </a:p>
@@ -4079,7 +4079,7 @@
                   <a:srgbClr val="4A4560"/>
                 </a:solidFill>
               </a:rPr>
-              <a:t>Dựng giao diện chính, thiết lập Firebase, CRUD, dữ liệu mẫu</a:t>
+              <a:t>Dựng giao diện Compose, database SQLite, CRUD, dữ liệu mẫu</a:t>
             </a:r>
             <a:endParaRPr lang="en-US" sz="1500" dirty="0"/>
           </a:p>
@@ -7641,7 +7641,7 @@
                   <a:srgbClr val="6E6888"/>
                 </a:solidFill>
               </a:rPr>
-              <a:t>subradar.app · Web/Mobile</a:t>
+              <a:t>iPhone · iPad · Mac</a:t>
             </a:r>
             <a:endParaRPr lang="en-US" sz="1200" dirty="0"/>
           </a:p>
@@ -7680,7 +7680,7 @@
                   <a:srgbClr val="0E6E64"/>
                 </a:solidFill>
               </a:rPr>
-              <a:t>+  Giao diện tối giản, dễ dùng</a:t>
+              <a:t>+  Báo cáo tuần/tháng/quý/năm, tag, nền tảng</a:t>
             </a:r>
             <a:endParaRPr lang="en-US" sz="1600" dirty="0"/>
           </a:p>
@@ -7697,7 +7697,7 @@
                   <a:srgbClr val="0E6E64"/>
                 </a:solidFill>
               </a:rPr>
-              <a:t>+  Theo dõi gói và ngày gia hạn rõ ràng</a:t>
+              <a:t>+  Nhắc trước hạn, thêm vào lịch, đồng bộ iCloud</a:t>
             </a:r>
             <a:endParaRPr lang="en-US" sz="1600" dirty="0"/>
           </a:p>
@@ -7714,7 +7714,7 @@
                   <a:srgbClr val="A23B22"/>
                 </a:solidFill>
               </a:rPr>
-              <a:t>−  Giao diện tiếng Anh</a:t>
+              <a:t>−  Không có Android, chỉ có tiếng Anh</a:t>
             </a:r>
             <a:endParaRPr lang="en-US" sz="1600" dirty="0"/>
           </a:p>
@@ -7731,7 +7731,7 @@
                   <a:srgbClr val="A23B22"/>
                 </a:solidFill>
               </a:rPr>
-              <a:t>−  Chưa sát thói quen dùng VND và dịch vụ trong nước</a:t>
+              <a:t>−  Một số tính năng cần gói Pro</a:t>
             </a:r>
             <a:endParaRPr lang="en-US" sz="1600" dirty="0"/>
           </a:p>
@@ -7888,7 +7888,7 @@
                   <a:srgbClr val="6E6888"/>
                 </a:solidFill>
               </a:rPr>
-              <a:t>iOS</a:t>
+              <a:t>iPhone</a:t>
             </a:r>
             <a:endParaRPr lang="en-US" sz="1200" dirty="0"/>
           </a:p>
@@ -7961,7 +7961,7 @@
                   <a:srgbClr val="A23B22"/>
                 </a:solidFill>
               </a:rPr>
-              <a:t>−  Chỉ có trên iOS</a:t>
+              <a:t>−  Chỉ có trên iPhone</a:t>
             </a:r>
             <a:endParaRPr lang="en-US" sz="1600" dirty="0"/>
           </a:p>
@@ -8135,7 +8135,7 @@
                   <a:srgbClr val="6E6888"/>
                 </a:solidFill>
               </a:rPr>
-              <a:t>iOS · Android · Web</a:t>
+              <a:t>Ứng dụng tài chính cá nhân</a:t>
             </a:r>
             <a:endParaRPr lang="en-US" sz="1200" dirty="0"/>
           </a:p>
@@ -8191,7 +8191,7 @@
                   <a:srgbClr val="0E6E64"/>
                 </a:solidFill>
               </a:rPr>
-              <a:t>+  Hỗ trợ hủy gói, quản lý ngân sách</a:t>
+              <a:t>+  Hủy gói hộ, quản lý ngân sách</a:t>
             </a:r>
             <a:endParaRPr lang="en-US" sz="1600" dirty="0"/>
           </a:p>
@@ -8225,7 +8225,7 @@
                   <a:srgbClr val="A23B22"/>
                 </a:solidFill>
               </a:rPr>
-              <a:t>−  Chủ yếu cho thị trường Mỹ; nhiều tính năng trả phí</a:t>
+              <a:t>−  Hủy gói hộ cần bản Premium trả phí; hướng tới thị trường Mỹ</a:t>
             </a:r>
             <a:endParaRPr lang="en-US" sz="1600" dirty="0"/>
           </a:p>
@@ -8345,7 +8345,7 @@
                   <a:schemeClr val="bg1"/>
                 </a:solidFill>
               </a:rPr>
-              <a:t>giao diện tiếng Việt, VND mặc định, nhập tay không cần liên kết ngân hàng, miễn phí, tập trung đúng nhu cầu nhắc hạn và thống kê.</a:t>
+              <a:t>app Android, giao diện tiếng Việt, VND mặc định, nhập tay không cần liên kết ngân hàng, dữ liệu lưu trên máy, miễn phí.</a:t>
             </a:r>
             <a:endParaRPr lang="en-US" sz="1600" dirty="0"/>
           </a:p>
@@ -8598,7 +8598,7 @@
                   <a:srgbClr val="4A4560"/>
                 </a:solidFill>
               </a:rPr>
-              <a:t>Tổng số gói, chi phí tháng ước tính, khoản sắp đến hạn, gói gần nhất.</a:t>
+              <a:t>Chi phí tháng ước tính, số gói đang hoạt động, số gói đến hạn ≤ 7 ngày.</a:t>
             </a:r>
             <a:endParaRPr lang="en-US" sz="1500" dirty="0"/>
           </a:p>
@@ -8743,7 +8743,7 @@
                   <a:srgbClr val="4A4560"/>
                 </a:solidFill>
               </a:rPr>
-              <a:t>Thêm, xem chi tiết, sửa, xóa gói; kiểm tra dữ liệu hợp lệ.</a:t>
+              <a:t>Thêm, xem, sửa, xóa gói; kiểm tra dữ liệu hợp lệ.</a:t>
             </a:r>
             <a:endParaRPr lang="en-US" sz="1500" dirty="0"/>
           </a:p>
@@ -8888,7 +8888,7 @@
                   <a:srgbClr val="4A4560"/>
                 </a:solidFill>
               </a:rPr>
-              <a:t>Tìm theo tên; lọc danh mục, trạng thái; sắp theo ngày hoặc chi phí.</a:t>
+              <a:t>Tìm theo tên, tag, nền tảng; lọc danh mục, trạng thái; sắp xếp 3 kiểu.</a:t>
             </a:r>
             <a:endParaRPr lang="en-US" sz="1500" dirty="0"/>
           </a:p>
@@ -9033,7 +9033,7 @@
                   <a:srgbClr val="4A4560"/>
                 </a:solidFill>
               </a:rPr>
-              <a:t>Danh sách khoản sắp đến hạn; thông báo cục bộ nếu đủ thời gian.</a:t>
+              <a:t>Vạch màu báo sắp gia hạn; thông báo cục bộ trước hạn.</a:t>
             </a:r>
             <a:endParaRPr lang="en-US" sz="1500" dirty="0"/>
           </a:p>
@@ -9178,7 +9178,7 @@
                   <a:srgbClr val="4A4560"/>
                 </a:solidFill>
               </a:rPr>
-              <a:t>Tổng chi theo tháng, phân bổ theo danh mục, gói chi phí cao.</a:t>
+              <a:t>Chi phí tuần/tháng/quý/năm, theo danh mục, gói tốn nhất.</a:t>
             </a:r>
             <a:endParaRPr lang="en-US" sz="1500" dirty="0"/>
           </a:p>
@@ -9323,7 +9323,7 @@
                   <a:srgbClr val="4A4560"/>
                 </a:solidFill>
               </a:rPr>
-              <a:t>Dữ liệu lưu trên database, mở lại app vẫn còn.</a:t>
+              <a:t>Dữ liệu lưu bằng SQLite trên máy, mở lại app vẫn còn.</a:t>
             </a:r>
             <a:endParaRPr lang="en-US" sz="1500" dirty="0"/>
           </a:p>
@@ -9467,7 +9467,7 @@
                   <a:schemeClr val="accent6"/>
                 </a:solidFill>
               </a:rPr>
-              <a:t>Làm sau khi MVP đã ổn định</a:t>
+              <a:t>4/5 chức năng mở rộng đã có trong app</a:t>
             </a:r>
             <a:endParaRPr lang="en-US" sz="1600" dirty="0"/>
           </a:p>
@@ -9475,7 +9475,7 @@
       </p:sp>
       <p:sp>
         <p:nvSpPr>
-          <p:cNvPr id="4" name="Đăng ký / đăng nhập circle"/>
+          <p:cNvPr id="4" name="Trạng thái gói  ✓ Đã làm circle"/>
           <p:cNvSpPr/>
           <p:nvPr/>
         </p:nvSpPr>
@@ -9488,14 +9488,14 @@
             <a:avLst/>
           </a:prstGeom>
           <a:solidFill>
-            <a:schemeClr val="accent1"/>
+            <a:schemeClr val="accent2"/>
           </a:solidFill>
           <a:ln/>
         </p:spPr>
       </p:sp>
       <p:pic>
         <p:nvPicPr>
-          <p:cNvPr id="5" name="Đăng ký / đăng nhập icon" descr="Đăng ký / đăng nhập">    </p:cNvPr>
+          <p:cNvPr id="5" name="Trạng thái gói  ✓ Đã làm icon" descr="Trạng thái gói  ✓ Đã làm">    </p:cNvPr>
           <p:cNvPicPr>
             <a:picLocks noChangeAspect="1"/>
           </p:cNvPicPr>
@@ -9547,7 +9547,7 @@
                   <a:schemeClr val="tx2"/>
                 </a:solidFill>
               </a:rPr>
-              <a:t>Đăng ký / đăng nhập</a:t>
+              <a:t>Trạng thái gói  ✓ Đã làm</a:t>
             </a:r>
             <a:endParaRPr lang="en-US" sz="1800" dirty="0"/>
           </a:p>
@@ -9583,7 +9583,7 @@
                   <a:srgbClr val="4A4560"/>
                 </a:solidFill>
               </a:rPr>
-              <a:t>Mỗi tài khoản chỉ xem dữ liệu của mình</a:t>
+              <a:t>Đang hoạt động, tạm dừng, đã hủy</a:t>
             </a:r>
             <a:endParaRPr lang="en-US" sz="1500" dirty="0"/>
           </a:p>
@@ -9591,7 +9591,7 @@
       </p:sp>
       <p:sp>
         <p:nvSpPr>
-          <p:cNvPr id="8" name="Trạng thái gói circle"/>
+          <p:cNvPr id="8" name="Biểu đồ chi phí  ✓ Đã làm circle"/>
           <p:cNvSpPr/>
           <p:nvPr/>
         </p:nvSpPr>
@@ -9604,14 +9604,14 @@
             <a:avLst/>
           </a:prstGeom>
           <a:solidFill>
-            <a:schemeClr val="accent2"/>
+            <a:schemeClr val="accent3"/>
           </a:solidFill>
           <a:ln/>
         </p:spPr>
       </p:sp>
       <p:pic>
         <p:nvPicPr>
-          <p:cNvPr id="9" name="Trạng thái gói icon" descr="Trạng thái gói">    </p:cNvPr>
+          <p:cNvPr id="9" name="Biểu đồ chi phí  ✓ Đã làm icon" descr="Biểu đồ chi phí  ✓ Đã làm">    </p:cNvPr>
           <p:cNvPicPr>
             <a:picLocks noChangeAspect="1"/>
           </p:cNvPicPr>
@@ -9663,7 +9663,7 @@
                   <a:schemeClr val="tx2"/>
                 </a:solidFill>
               </a:rPr>
-              <a:t>Trạng thái gói</a:t>
+              <a:t>Biểu đồ chi phí  ✓ Đã làm</a:t>
             </a:r>
             <a:endParaRPr lang="en-US" sz="1800" dirty="0"/>
           </a:p>
@@ -9699,7 +9699,7 @@
                   <a:srgbClr val="4A4560"/>
                 </a:solidFill>
               </a:rPr>
-              <a:t>Đang hoạt động, tạm ngưng, đã hủy</a:t>
+              <a:t>Biểu đồ tròn theo gói, thanh theo danh mục</a:t>
             </a:r>
             <a:endParaRPr lang="en-US" sz="1500" dirty="0"/>
           </a:p>
@@ -9707,7 +9707,7 @@
       </p:sp>
       <p:sp>
         <p:nvSpPr>
-          <p:cNvPr id="12" name="Biểu đồ chi phí circle"/>
+          <p:cNvPr id="12" name="Tùy chọn thời gian nhắc  ✓ Đã làm circle"/>
           <p:cNvSpPr/>
           <p:nvPr/>
         </p:nvSpPr>
@@ -9720,14 +9720,14 @@
             <a:avLst/>
           </a:prstGeom>
           <a:solidFill>
-            <a:schemeClr val="accent3"/>
+            <a:schemeClr val="accent4"/>
           </a:solidFill>
           <a:ln/>
         </p:spPr>
       </p:sp>
       <p:pic>
         <p:nvPicPr>
-          <p:cNvPr id="13" name="Biểu đồ chi phí icon" descr="Biểu đồ chi phí">    </p:cNvPr>
+          <p:cNvPr id="13" name="Tùy chọn thời gian nhắc  ✓ Đã làm icon" descr="Tùy chọn thời gian nhắc  ✓ Đã làm">    </p:cNvPr>
           <p:cNvPicPr>
             <a:picLocks noChangeAspect="1"/>
           </p:cNvPicPr>
@@ -9779,7 +9779,7 @@
                   <a:schemeClr val="tx2"/>
                 </a:solidFill>
               </a:rPr>
-              <a:t>Biểu đồ chi phí</a:t>
+              <a:t>Tùy chọn thời gian nhắc  ✓ Đã làm</a:t>
             </a:r>
             <a:endParaRPr lang="en-US" sz="1800" dirty="0"/>
           </a:p>
@@ -9815,7 +9815,7 @@
                   <a:srgbClr val="4A4560"/>
                 </a:solidFill>
               </a:rPr>
-              <a:t>Theo tháng và theo danh mục</a:t>
+              <a:t>Đúng ngày hoặc trước 1, 3, 7, 30 ngày</a:t>
             </a:r>
             <a:endParaRPr lang="en-US" sz="1500" dirty="0"/>
           </a:p>
@@ -9823,7 +9823,7 @@
       </p:sp>
       <p:sp>
         <p:nvSpPr>
-          <p:cNvPr id="16" name="Tùy chọn thời gian nhắc circle"/>
+          <p:cNvPr id="16" name="Xuất CSV, chia sẻ báo cáo  ✓ Đã làm circle"/>
           <p:cNvSpPr/>
           <p:nvPr/>
         </p:nvSpPr>
@@ -9836,14 +9836,14 @@
             <a:avLst/>
           </a:prstGeom>
           <a:solidFill>
-            <a:schemeClr val="accent4"/>
+            <a:schemeClr val="accent5"/>
           </a:solidFill>
           <a:ln/>
         </p:spPr>
       </p:sp>
       <p:pic>
         <p:nvPicPr>
-          <p:cNvPr id="17" name="Tùy chọn thời gian nhắc icon" descr="Tùy chọn thời gian nhắc">    </p:cNvPr>
+          <p:cNvPr id="17" name="Xuất CSV, chia sẻ báo cáo  ✓ Đã làm icon" descr="Xuất CSV, chia sẻ báo cáo  ✓ Đã làm">    </p:cNvPr>
           <p:cNvPicPr>
             <a:picLocks noChangeAspect="1"/>
           </p:cNvPicPr>
@@ -9895,7 +9895,7 @@
                   <a:schemeClr val="tx2"/>
                 </a:solidFill>
               </a:rPr>
-              <a:t>Tùy chọn thời gian nhắc</a:t>
+              <a:t>Xuất CSV, chia sẻ báo cáo  ✓ Đã làm</a:t>
             </a:r>
             <a:endParaRPr lang="en-US" sz="1800" dirty="0"/>
           </a:p>
@@ -9931,7 +9931,7 @@
                   <a:srgbClr val="4A4560"/>
                 </a:solidFill>
               </a:rPr>
-              <a:t>Nhắc trước 1, 3 hoặc 7 ngày</a:t>
+              <a:t>Sao lưu danh sách, gửi báo cáo chi phí</a:t>
             </a:r>
             <a:endParaRPr lang="en-US" sz="1500" dirty="0"/>
           </a:p>
@@ -9939,7 +9939,7 @@
       </p:sp>
       <p:sp>
         <p:nvSpPr>
-          <p:cNvPr id="20" name="Xuất CSV, chia sẻ báo cáo circle"/>
+          <p:cNvPr id="20" name="Đăng nhập, đồng bộ đám mây circle"/>
           <p:cNvSpPr/>
           <p:nvPr/>
         </p:nvSpPr>
@@ -9952,14 +9952,14 @@
             <a:avLst/>
           </a:prstGeom>
           <a:solidFill>
-            <a:schemeClr val="accent5"/>
+            <a:schemeClr val="accent1"/>
           </a:solidFill>
           <a:ln/>
         </p:spPr>
       </p:sp>
       <p:pic>
         <p:nvPicPr>
-          <p:cNvPr id="21" name="Xuất CSV, chia sẻ báo cáo icon" descr="Xuất CSV, chia sẻ báo cáo">    </p:cNvPr>
+          <p:cNvPr id="21" name="Đăng nhập, đồng bộ đám mây icon" descr="Đăng nhập, đồng bộ đám mây">    </p:cNvPr>
           <p:cNvPicPr>
             <a:picLocks noChangeAspect="1"/>
           </p:cNvPicPr>
@@ -10011,7 +10011,7 @@
                   <a:schemeClr val="tx2"/>
                 </a:solidFill>
               </a:rPr>
-              <a:t>Xuất CSV, chia sẻ báo cáo</a:t>
+              <a:t>Đăng nhập, đồng bộ đám mây</a:t>
             </a:r>
             <a:endParaRPr lang="en-US" sz="1800" dirty="0"/>
           </a:p>
@@ -10047,7 +10047,7 @@
                   <a:srgbClr val="4A4560"/>
                 </a:solidFill>
               </a:rPr>
-              <a:t>Sao lưu danh sách, gửi báo cáo chi phí</a:t>
+              <a:t>Chưa làm – cần Firebase</a:t>
             </a:r>
             <a:endParaRPr lang="en-US" sz="1500" dirty="0"/>
           </a:p>
@@ -10519,7 +10519,7 @@
                   <a:srgbClr val="4A4560"/>
                 </a:solidFill>
               </a:rPr>
-              <a:t>Người dùng, Firebase Auth, Hệ thống thông báo</a:t>
+              <a:t>Người dùng, Hệ thống thông báo, Ứng dụng Lịch</a:t>
             </a:r>
             <a:endParaRPr lang="en-US" sz="1400" dirty="0"/>
           </a:p>
@@ -10527,7 +10527,7 @@
       </p:sp>
       <p:sp>
         <p:nvSpPr>
-          <p:cNvPr id="8" name="Số liệu use case chính"/>
+          <p:cNvPr id="8" name="Số liệu use case đã làm"/>
           <p:cNvSpPr/>
           <p:nvPr/>
         </p:nvSpPr>
@@ -10587,7 +10587,7 @@
                 <a:ea typeface="Cambria" pitchFamily="34" charset="-122"/>
                 <a:cs typeface="Cambria" pitchFamily="34" charset="-120"/>
               </a:rPr>
-              <a:t>10</a:t>
+              <a:t>14</a:t>
             </a:r>
             <a:endParaRPr lang="en-US" sz="4400" dirty="0"/>
           </a:p>
@@ -10623,7 +10623,7 @@
                   <a:schemeClr val="tx2"/>
                 </a:solidFill>
               </a:rPr>
-              <a:t>use case chính</a:t>
+              <a:t>use case đã làm</a:t>
             </a:r>
             <a:endParaRPr lang="en-US" sz="1800" dirty="0"/>
           </a:p>
@@ -10659,7 +10659,7 @@
                   <a:srgbClr val="4A4560"/>
                 </a:solidFill>
               </a:rPr>
-              <a:t>CRUD, Dashboard, tìm kiếm, thống kê, nhắc hạn</a:t>
+              <a:t>CRUD, tổng quan, tìm kiếm, báo cáo, tag, nhắc hạn, CSV</a:t>
             </a:r>
             <a:endParaRPr lang="en-US" sz="1400" dirty="0"/>
           </a:p>
@@ -10667,7 +10667,7 @@
       </p:sp>
       <p:sp>
         <p:nvSpPr>
-          <p:cNvPr id="12" name="Số liệu use case mở rộng"/>
+          <p:cNvPr id="12" name="Số liệu hướng phát triển"/>
           <p:cNvSpPr/>
           <p:nvPr/>
         </p:nvSpPr>
@@ -10727,7 +10727,7 @@
                 <a:ea typeface="Cambria" pitchFamily="34" charset="-122"/>
                 <a:cs typeface="Cambria" pitchFamily="34" charset="-120"/>
               </a:rPr>
-              <a:t>5</a:t>
+              <a:t>1</a:t>
             </a:r>
             <a:endParaRPr lang="en-US" sz="4400" dirty="0"/>
           </a:p>
@@ -10763,7 +10763,7 @@
                   <a:schemeClr val="tx2"/>
                 </a:solidFill>
               </a:rPr>
-              <a:t>use case mở rộng</a:t>
+              <a:t>hướng phát triển</a:t>
             </a:r>
             <a:endParaRPr lang="en-US" sz="1800" dirty="0"/>
           </a:p>
@@ -10799,7 +10799,7 @@
                   <a:srgbClr val="4A4560"/>
                 </a:solidFill>
               </a:rPr>
-              <a:t>Đăng nhập, trạng thái, thời gian nhắc, biểu đồ, xuất CSV</a:t>
+              <a:t>Đăng nhập, đồng bộ đám mây</a:t>
             </a:r>
             <a:endParaRPr lang="en-US" sz="1400" dirty="0"/>
           </a:p>
@@ -10987,7 +10987,7 @@
       </p:sp>
       <p:sp>
         <p:nvSpPr>
-          <p:cNvPr id="4" name="Tầng Giao diện (Screens, Widgets)"/>
+          <p:cNvPr id="4" name="Tầng Giao diện (Compose)"/>
           <p:cNvSpPr/>
           <p:nvPr/>
         </p:nvSpPr>
@@ -11037,7 +11037,7 @@
                   <a:schemeClr val="bg1"/>
                 </a:solidFill>
               </a:rPr>
-              <a:t>Giao diện (Screens, Widgets)</a:t>
+              <a:t>Giao diện (Compose)</a:t>
             </a:r>
             <a:endParaRPr lang="en-US" sz="1500" dirty="0"/>
           </a:p>
@@ -11051,7 +11051,7 @@
                   <a:schemeClr val="bg1"/>
                 </a:solidFill>
               </a:rPr>
-              <a:t>Flutter · Dart</a:t>
+              <a:t>Màn hình, Navigation Compose</a:t>
             </a:r>
             <a:endParaRPr lang="en-US" sz="1500" dirty="0"/>
           </a:p>
@@ -11083,7 +11083,7 @@
       </p:pic>
       <p:sp>
         <p:nvSpPr>
-          <p:cNvPr id="7" name="Tầng Repository / Service"/>
+          <p:cNvPr id="7" name="Tầng ViewModel · Repository"/>
           <p:cNvSpPr/>
           <p:nvPr/>
         </p:nvSpPr>
@@ -11133,7 +11133,7 @@
                   <a:schemeClr val="bg1"/>
                 </a:solidFill>
               </a:rPr>
-              <a:t>Repository / Service</a:t>
+              <a:t>ViewModel · Repository</a:t>
             </a:r>
             <a:endParaRPr lang="en-US" sz="1500" dirty="0"/>
           </a:p>
@@ -11147,7 +11147,7 @@
                   <a:schemeClr val="bg1"/>
                 </a:solidFill>
               </a:rPr>
-              <a:t>Tách UI khỏi truy cập dữ liệu</a:t>
+              <a:t>StateFlow, tách UI khỏi dữ liệu</a:t>
             </a:r>
             <a:endParaRPr lang="en-US" sz="1500" dirty="0"/>
           </a:p>
@@ -11179,7 +11179,7 @@
       </p:pic>
       <p:sp>
         <p:nvSpPr>
-          <p:cNvPr id="10" name="Tầng Firebase"/>
+          <p:cNvPr id="10" name="Tầng SQLite trên máy"/>
           <p:cNvSpPr/>
           <p:nvPr/>
         </p:nvSpPr>
@@ -11229,7 +11229,7 @@
                   <a:schemeClr val="bg1"/>
                 </a:solidFill>
               </a:rPr>
-              <a:t>Firebase</a:t>
+              <a:t>SQLite trên máy</a:t>
             </a:r>
             <a:endParaRPr lang="en-US" sz="1500" dirty="0"/>
           </a:p>
@@ -11243,7 +11243,7 @@
                   <a:schemeClr val="bg1"/>
                 </a:solidFill>
               </a:rPr>
-              <a:t>Firestore · Authentication</a:t>
+              <a:t>SQLiteOpenHelper · SharedPreferences</a:t>
             </a:r>
             <a:endParaRPr lang="en-US" sz="1500" dirty="0"/>
           </a:p>
@@ -11251,7 +11251,7 @@
       </p:sp>
       <p:sp>
         <p:nvSpPr>
-          <p:cNvPr id="12" name="Thẻ Flutter 3 (Dart)"/>
+          <p:cNvPr id="12" name="Thẻ Kotlin, Jetpack Compose"/>
           <p:cNvSpPr/>
           <p:nvPr/>
         </p:nvSpPr>
@@ -11280,7 +11280,7 @@
       </p:sp>
       <p:sp>
         <p:nvSpPr>
-          <p:cNvPr id="13" name="Flutter 3 (Dart) circle"/>
+          <p:cNvPr id="13" name="Kotlin, Jetpack Compose circle"/>
           <p:cNvSpPr/>
           <p:nvPr/>
         </p:nvSpPr>
@@ -11300,7 +11300,7 @@
       </p:sp>
       <p:pic>
         <p:nvPicPr>
-          <p:cNvPr id="14" name="Flutter 3 (Dart) icon" descr="Flutter 3 (Dart)">    </p:cNvPr>
+          <p:cNvPr id="14" name="Kotlin, Jetpack Compose icon" descr="Kotlin, Jetpack Compose">    </p:cNvPr>
           <p:cNvPicPr>
             <a:picLocks noChangeAspect="1"/>
           </p:cNvPicPr>
@@ -11352,7 +11352,7 @@
                   <a:schemeClr val="tx2"/>
                 </a:solidFill>
               </a:rPr>
-              <a:t>Flutter 3 (Dart)</a:t>
+              <a:t>Kotlin, Jetpack Compose</a:t>
             </a:r>
             <a:endParaRPr lang="en-US" sz="1500" dirty="0"/>
           </a:p>
@@ -11388,7 +11388,7 @@
                   <a:srgbClr val="4A4560"/>
                 </a:solidFill>
               </a:rPr>
-              <a:t>Một mã nguồn chạy Android và iOS, hot reload</a:t>
+              <a:t>Android native, Material 3, sáng/tối</a:t>
             </a:r>
             <a:endParaRPr lang="en-US" sz="1400" dirty="0"/>
           </a:p>
@@ -11396,7 +11396,7 @@
       </p:sp>
       <p:sp>
         <p:nvSpPr>
-          <p:cNvPr id="17" name="Thẻ Cloud Firestore"/>
+          <p:cNvPr id="17" name="Thẻ SQLite"/>
           <p:cNvSpPr/>
           <p:nvPr/>
         </p:nvSpPr>
@@ -11425,7 +11425,7 @@
       </p:sp>
       <p:sp>
         <p:nvSpPr>
-          <p:cNvPr id="18" name="Cloud Firestore circle"/>
+          <p:cNvPr id="18" name="SQLite circle"/>
           <p:cNvSpPr/>
           <p:nvPr/>
         </p:nvSpPr>
@@ -11445,7 +11445,7 @@
       </p:sp>
       <p:pic>
         <p:nvPicPr>
-          <p:cNvPr id="19" name="Cloud Firestore icon" descr="Cloud Firestore">    </p:cNvPr>
+          <p:cNvPr id="19" name="SQLite icon" descr="SQLite">    </p:cNvPr>
           <p:cNvPicPr>
             <a:picLocks noChangeAspect="1"/>
           </p:cNvPicPr>
@@ -11497,7 +11497,7 @@
                   <a:schemeClr val="tx2"/>
                 </a:solidFill>
               </a:rPr>
-              <a:t>Cloud Firestore</a:t>
+              <a:t>SQLite</a:t>
             </a:r>
             <a:endParaRPr lang="en-US" sz="1500" dirty="0"/>
           </a:p>
@@ -11533,7 +11533,7 @@
                   <a:srgbClr val="4A4560"/>
                 </a:solidFill>
               </a:rPr>
-              <a:t>Database online, realtime, không cần tự viết server</a:t>
+              <a:t>Lưu offline trên máy, không cần server</a:t>
             </a:r>
             <a:endParaRPr lang="en-US" sz="1400" dirty="0"/>
           </a:p>
@@ -11541,7 +11541,7 @@
       </p:sp>
       <p:sp>
         <p:nvSpPr>
-          <p:cNvPr id="22" name="Thẻ Firebase Authentication"/>
+          <p:cNvPr id="22" name="Thẻ ViewModel, StateFlow"/>
           <p:cNvSpPr/>
           <p:nvPr/>
         </p:nvSpPr>
@@ -11570,7 +11570,7 @@
       </p:sp>
       <p:sp>
         <p:nvSpPr>
-          <p:cNvPr id="23" name="Firebase Authentication circle"/>
+          <p:cNvPr id="23" name="ViewModel, StateFlow circle"/>
           <p:cNvSpPr/>
           <p:nvPr/>
         </p:nvSpPr>
@@ -11590,7 +11590,7 @@
       </p:sp>
       <p:pic>
         <p:nvPicPr>
-          <p:cNvPr id="24" name="Firebase Authentication icon" descr="Firebase Authentication">    </p:cNvPr>
+          <p:cNvPr id="24" name="ViewModel, StateFlow icon" descr="ViewModel, StateFlow">    </p:cNvPr>
           <p:cNvPicPr>
             <a:picLocks noChangeAspect="1"/>
           </p:cNvPicPr>
@@ -11642,7 +11642,7 @@
                   <a:schemeClr val="tx2"/>
                 </a:solidFill>
               </a:rPr>
-              <a:t>Firebase Authentication</a:t>
+              <a:t>ViewModel, StateFlow</a:t>
             </a:r>
             <a:endParaRPr lang="en-US" sz="1500" dirty="0"/>
           </a:p>
@@ -11678,7 +11678,7 @@
                   <a:srgbClr val="4A4560"/>
                 </a:solidFill>
               </a:rPr>
-              <a:t>Đăng ký, đăng nhập bằng email (mở rộng)</a:t>
+              <a:t>Quản lý trạng thái, Repository pattern</a:t>
             </a:r>
             <a:endParaRPr lang="en-US" sz="1400" dirty="0"/>
           </a:p>
@@ -11686,7 +11686,7 @@
       </p:sp>
       <p:sp>
         <p:nvSpPr>
-          <p:cNvPr id="27" name="Thẻ flutter_local_notifications"/>
+          <p:cNvPr id="27" name="Thẻ WorkManager"/>
           <p:cNvSpPr/>
           <p:nvPr/>
         </p:nvSpPr>
@@ -11715,7 +11715,7 @@
       </p:sp>
       <p:sp>
         <p:nvSpPr>
-          <p:cNvPr id="28" name="flutter_local_notifications circle"/>
+          <p:cNvPr id="28" name="WorkManager circle"/>
           <p:cNvSpPr/>
           <p:nvPr/>
         </p:nvSpPr>
@@ -11735,7 +11735,7 @@
       </p:sp>
       <p:pic>
         <p:nvPicPr>
-          <p:cNvPr id="29" name="flutter_local_notifications icon" descr="flutter_local_notifications">    </p:cNvPr>
+          <p:cNvPr id="29" name="WorkManager icon" descr="WorkManager">    </p:cNvPr>
           <p:cNvPicPr>
             <a:picLocks noChangeAspect="1"/>
           </p:cNvPicPr>
@@ -11787,7 +11787,7 @@
                   <a:schemeClr val="tx2"/>
                 </a:solidFill>
               </a:rPr>
-              <a:t>flutter_local_notifications</a:t>
+              <a:t>WorkManager</a:t>
             </a:r>
             <a:endParaRPr lang="en-US" sz="1500" dirty="0"/>
           </a:p>
@@ -11823,7 +11823,7 @@
                   <a:srgbClr val="4A4560"/>
                 </a:solidFill>
               </a:rPr>
-              <a:t>Thông báo nhắc hạn thanh toán</a:t>
+              <a:t>Kiểm tra hằng ngày, thông báo nhắc hạn</a:t>
             </a:r>
             <a:endParaRPr lang="en-US" sz="1400" dirty="0"/>
           </a:p>
@@ -11831,7 +11831,7 @@
       </p:sp>
       <p:sp>
         <p:nvSpPr>
-          <p:cNvPr id="32" name="Thẻ fl_chart"/>
+          <p:cNvPr id="32" name="Thẻ Compose Canvas"/>
           <p:cNvSpPr/>
           <p:nvPr/>
         </p:nvSpPr>
@@ -11860,7 +11860,7 @@
       </p:sp>
       <p:sp>
         <p:nvSpPr>
-          <p:cNvPr id="33" name="fl_chart circle"/>
+          <p:cNvPr id="33" name="Compose Canvas circle"/>
           <p:cNvSpPr/>
           <p:nvPr/>
         </p:nvSpPr>
@@ -11880,7 +11880,7 @@
       </p:sp>
       <p:pic>
         <p:nvPicPr>
-          <p:cNvPr id="34" name="fl_chart icon" descr="fl_chart">    </p:cNvPr>
+          <p:cNvPr id="34" name="Compose Canvas icon" descr="Compose Canvas">    </p:cNvPr>
           <p:cNvPicPr>
             <a:picLocks noChangeAspect="1"/>
           </p:cNvPicPr>
@@ -11932,7 +11932,7 @@
                   <a:schemeClr val="tx2"/>
                 </a:solidFill>
               </a:rPr>
-              <a:t>fl_chart</a:t>
+              <a:t>Compose Canvas</a:t>
             </a:r>
             <a:endParaRPr lang="en-US" sz="1500" dirty="0"/>
           </a:p>
@@ -11968,7 +11968,7 @@
                   <a:srgbClr val="4A4560"/>
                 </a:solidFill>
               </a:rPr>
-              <a:t>Vẽ biểu đồ chi phí</a:t>
+              <a:t>Tự vẽ biểu đồ tròn, không cần thư viện</a:t>
             </a:r>
             <a:endParaRPr lang="en-US" sz="1400" dirty="0"/>
           </a:p>
@@ -11976,7 +11976,7 @@
       </p:sp>
       <p:sp>
         <p:nvSpPr>
-          <p:cNvPr id="37" name="Thẻ Git, GitHub, Figma"/>
+          <p:cNvPr id="37" name="Thẻ Gradle, JUnit, GitHub"/>
           <p:cNvSpPr/>
           <p:nvPr/>
         </p:nvSpPr>
@@ -12005,7 +12005,7 @@
       </p:sp>
       <p:sp>
         <p:nvSpPr>
-          <p:cNvPr id="38" name="Git, GitHub, Figma circle"/>
+          <p:cNvPr id="38" name="Gradle, JUnit, GitHub circle"/>
           <p:cNvSpPr/>
           <p:nvPr/>
         </p:nvSpPr>
@@ -12025,7 +12025,7 @@
       </p:sp>
       <p:pic>
         <p:nvPicPr>
-          <p:cNvPr id="39" name="Git, GitHub, Figma icon" descr="Git, GitHub, Figma">    </p:cNvPr>
+          <p:cNvPr id="39" name="Gradle, JUnit, GitHub icon" descr="Gradle, JUnit, GitHub">    </p:cNvPr>
           <p:cNvPicPr>
             <a:picLocks noChangeAspect="1"/>
           </p:cNvPicPr>
@@ -12077,7 +12077,7 @@
                   <a:schemeClr val="tx2"/>
                 </a:solidFill>
               </a:rPr>
-              <a:t>Git, GitHub, Figma</a:t>
+              <a:t>Gradle, JUnit, GitHub</a:t>
             </a:r>
             <a:endParaRPr lang="en-US" sz="1500" dirty="0"/>
           </a:p>
@@ -12113,7 +12113,7 @@
                   <a:srgbClr val="4A4560"/>
                 </a:solidFill>
               </a:rPr>
-              <a:t>Quản lý mã nguồn, review; thiết kế wireframe</a:t>
+              <a:t>AGP 9.3, unit test, quản lý mã nguồn</a:t>
             </a:r>
             <a:endParaRPr lang="en-US" sz="1400" dirty="0"/>
           </a:p>

</xml_diff>